<commit_message>
Update final project presentation
</commit_message>
<xml_diff>
--- a/DevOps_Final_Project.pptx
+++ b/DevOps_Final_Project.pptx
@@ -117,33 +117,33 @@
   <p:extLst>
     <p:ext uri="{521415D9-36F7-43E2-AB2F-B90AF26B5E84}">
       <p14:sectionLst xmlns:p14="http://schemas.microsoft.com/office/powerpoint/2010/main">
-        <p14:section name="Intro" id="{8bf9d588-dd5e-1469-51ea-f391396345fc}">
+        <p14:section name="Intro" id="{a785c65d-c829-c718-eb9f-1960a4a7ccaa}">
           <p14:sldIdLst>
             <p14:sldId id="256"/>
             <p14:sldId id="257"/>
           </p14:sldIdLst>
         </p14:section>
-        <p14:section name="Build" id="{39100d28-5714-5855-72c6-cb42399fafaf}">
+        <p14:section name="Build" id="{86aaba90-e9e5-3130-0e3d-5cf2dcd35eda}">
           <p14:sldIdLst>
             <p14:sldId id="258"/>
             <p14:sldId id="259"/>
             <p14:sldId id="260"/>
           </p14:sldIdLst>
         </p14:section>
-        <p14:section name="Ship" id="{5a17241e-e8d5-eeeb-2861-dd599ed1a0d0}">
+        <p14:section name="Ship" id="{7612600b-8b4e-dd81-5c78-d46baf366228}">
           <p14:sldIdLst>
             <p14:sldId id="261"/>
             <p14:sldId id="262"/>
           </p14:sldIdLst>
         </p14:section>
-        <p14:section name="Run" id="{379ee106-f5d9-33eb-fce8-b83da498c387}">
+        <p14:section name="Run" id="{253fa15d-6c5b-507f-83fb-8ffa0ce764dc}">
           <p14:sldIdLst>
             <p14:sldId id="263"/>
             <p14:sldId id="264"/>
             <p14:sldId id="265"/>
           </p14:sldIdLst>
         </p14:section>
-        <p14:section name="Close" id="{6b2ab5b4-1392-2af1-d0c8-fef255a1ce3c}">
+        <p14:section name="Close" id="{5c6457da-ca80-dacd-f680-890c8c169749}">
           <p14:sldIdLst>
             <p14:sldId id="266"/>
           </p14:sldIdLst>
@@ -8348,7 +8348,7 @@
                   <a:schemeClr val="tx1"/>
                 </a:solidFill>
               </a:rPr>
-              <a:t>plan / apply not run: no AWS credentials</a:t>
+              <a:t>plan → apply → destroy run on a local AWS mock (Moto): EKS + node group ACTIVE</a:t>
             </a:r>
             <a:endParaRPr lang="en-US" sz="1500" dirty="0"/>
           </a:p>

</xml_diff>